<commit_message>
Gunakan tautan produksi Vercel pada laporan dan presentasi
Tautan lama menunjuk ke satu deployment tetap yang masih memuat tampilan
versi sebelumnya.
</commit_message>
<xml_diff>
--- a/laporan/Presentasi-K1-Playfair-Cipher.pptx
+++ b/laporan/Presentasi-K1-Playfair-Cipher.pptx
@@ -3585,7 +3585,7 @@
                   </a:extLst>
                 </a:hlinkClick>
               </a:rPr>
-              <a:t>ki-k1-fw4qxggdu-afdha5678s-projects.vercel.app</a:t>
+              <a:t>ki-k1.vercel.app</a:t>
             </a:r>
             <a:endParaRPr lang="en-US" sz="1100" dirty="0"/>
           </a:p>
@@ -9598,7 +9598,7 @@
                   </a:extLst>
                 </a:hlinkClick>
               </a:rPr>
-              <a:t>ki-k1-fw4qxggdu-afdha5678s-projects.vercel.app</a:t>
+              <a:t>ki-k1.vercel.app</a:t>
             </a:r>
             <a:endParaRPr lang="en-US" sz="1100" dirty="0"/>
           </a:p>

</xml_diff>